<commit_message>
update comment for coding
</commit_message>
<xml_diff>
--- a/Blog App Flutter + Laravel REST API.pptx
+++ b/Blog App Flutter + Laravel REST API.pptx
@@ -3507,476 +3507,6 @@
       </p:sp>
       <p:sp>
         <p:nvSpPr>
-          <p:cNvPr id="7" name="Text 3">
-            <a:extLst>
-              <a:ext uri="{FF2B5EF4-FFF2-40B4-BE49-F238E27FC236}">
-                <a16:creationId xmlns:a16="http://schemas.microsoft.com/office/drawing/2014/main" id="{FCA288CA-6CC8-B4C6-D223-C0FE4F36B582}"/>
-              </a:ext>
-            </a:extLst>
-          </p:cNvPr>
-          <p:cNvSpPr/>
-          <p:nvPr/>
-        </p:nvSpPr>
-        <p:spPr>
-          <a:xfrm>
-            <a:off x="2820079" y="1930566"/>
-            <a:ext cx="3571875" cy="132159"/>
-          </a:xfrm>
-          <a:prstGeom prst="rect">
-            <a:avLst/>
-          </a:prstGeom>
-          <a:noFill/>
-          <a:ln/>
-        </p:spPr>
-        <p:txBody>
-          <a:bodyPr wrap="square" lIns="204089" tIns="0" rIns="0" bIns="0" rtlCol="0" anchor="t">
-            <a:spAutoFit/>
-          </a:bodyPr>
-          <a:lstStyle/>
-          <a:p>
-            <a:pPr marL="0" indent="0" algn="l">
-              <a:buNone/>
-            </a:pPr>
-            <a:r>
-              <a:rPr lang="en-US" sz="850" dirty="0">
-                <a:solidFill>
-                  <a:srgbClr val="F8FAFC"/>
-                </a:solidFill>
-                <a:latin typeface="Kantumruy Pro" pitchFamily="34" charset="0"/>
-                <a:ea typeface="Kantumruy Pro" pitchFamily="34" charset="-122"/>
-                <a:cs typeface="Kantumruy Pro" pitchFamily="34" charset="-120"/>
-              </a:rPr>
-              <a:t>View &amp; Search Posts</a:t>
-            </a:r>
-            <a:endParaRPr lang="en-US" sz="850" dirty="0"/>
-          </a:p>
-        </p:txBody>
-      </p:sp>
-      <p:sp>
-        <p:nvSpPr>
-          <p:cNvPr id="8" name="Text 4">
-            <a:extLst>
-              <a:ext uri="{FF2B5EF4-FFF2-40B4-BE49-F238E27FC236}">
-                <a16:creationId xmlns:a16="http://schemas.microsoft.com/office/drawing/2014/main" id="{51CDC4C7-B797-2344-C831-A3ED0DB910CD}"/>
-              </a:ext>
-            </a:extLst>
-          </p:cNvPr>
-          <p:cNvSpPr/>
-          <p:nvPr/>
-        </p:nvSpPr>
-        <p:spPr>
-          <a:xfrm>
-            <a:off x="2820079" y="2148451"/>
-            <a:ext cx="3571875" cy="132159"/>
-          </a:xfrm>
-          <a:prstGeom prst="rect">
-            <a:avLst/>
-          </a:prstGeom>
-          <a:noFill/>
-          <a:ln/>
-        </p:spPr>
-        <p:txBody>
-          <a:bodyPr wrap="square" lIns="204089" tIns="0" rIns="0" bIns="0" rtlCol="0" anchor="t">
-            <a:spAutoFit/>
-          </a:bodyPr>
-          <a:lstStyle/>
-          <a:p>
-            <a:pPr marL="0" indent="0" algn="l">
-              <a:buNone/>
-            </a:pPr>
-            <a:r>
-              <a:rPr lang="en-US" sz="850" dirty="0">
-                <a:solidFill>
-                  <a:srgbClr val="F8FAFC"/>
-                </a:solidFill>
-                <a:latin typeface="Kantumruy Pro" pitchFamily="34" charset="0"/>
-                <a:ea typeface="Kantumruy Pro" pitchFamily="34" charset="-122"/>
-                <a:cs typeface="Kantumruy Pro" pitchFamily="34" charset="-120"/>
-              </a:rPr>
-              <a:t>View Post Details</a:t>
-            </a:r>
-            <a:endParaRPr lang="en-US" sz="850" dirty="0"/>
-          </a:p>
-        </p:txBody>
-      </p:sp>
-      <p:sp>
-        <p:nvSpPr>
-          <p:cNvPr id="9" name="Text 5">
-            <a:extLst>
-              <a:ext uri="{FF2B5EF4-FFF2-40B4-BE49-F238E27FC236}">
-                <a16:creationId xmlns:a16="http://schemas.microsoft.com/office/drawing/2014/main" id="{C1D7A9A5-B711-4072-CFB4-BAAED82774A2}"/>
-              </a:ext>
-            </a:extLst>
-          </p:cNvPr>
-          <p:cNvSpPr/>
-          <p:nvPr/>
-        </p:nvSpPr>
-        <p:spPr>
-          <a:xfrm>
-            <a:off x="2820079" y="2366335"/>
-            <a:ext cx="3571875" cy="132159"/>
-          </a:xfrm>
-          <a:prstGeom prst="rect">
-            <a:avLst/>
-          </a:prstGeom>
-          <a:noFill/>
-          <a:ln/>
-        </p:spPr>
-        <p:txBody>
-          <a:bodyPr wrap="square" lIns="204089" tIns="0" rIns="0" bIns="0" rtlCol="0" anchor="t">
-            <a:spAutoFit/>
-          </a:bodyPr>
-          <a:lstStyle/>
-          <a:p>
-            <a:pPr marL="0" indent="0" algn="l">
-              <a:buNone/>
-            </a:pPr>
-            <a:r>
-              <a:rPr lang="en-US" sz="850" dirty="0">
-                <a:solidFill>
-                  <a:srgbClr val="F8FAFC"/>
-                </a:solidFill>
-                <a:latin typeface="Kantumruy Pro" pitchFamily="34" charset="0"/>
-                <a:ea typeface="Kantumruy Pro" pitchFamily="34" charset="-122"/>
-                <a:cs typeface="Kantumruy Pro" pitchFamily="34" charset="-120"/>
-              </a:rPr>
-              <a:t>Create &amp; Edit Post</a:t>
-            </a:r>
-            <a:endParaRPr lang="en-US" sz="850" dirty="0"/>
-          </a:p>
-        </p:txBody>
-      </p:sp>
-      <p:sp>
-        <p:nvSpPr>
-          <p:cNvPr id="10" name="Text 6">
-            <a:extLst>
-              <a:ext uri="{FF2B5EF4-FFF2-40B4-BE49-F238E27FC236}">
-                <a16:creationId xmlns:a16="http://schemas.microsoft.com/office/drawing/2014/main" id="{4704F3BE-9B0D-6A99-914B-F0D88207C97B}"/>
-              </a:ext>
-            </a:extLst>
-          </p:cNvPr>
-          <p:cNvSpPr/>
-          <p:nvPr/>
-        </p:nvSpPr>
-        <p:spPr>
-          <a:xfrm>
-            <a:off x="2820079" y="2584220"/>
-            <a:ext cx="3571875" cy="132159"/>
-          </a:xfrm>
-          <a:prstGeom prst="rect">
-            <a:avLst/>
-          </a:prstGeom>
-          <a:noFill/>
-          <a:ln/>
-        </p:spPr>
-        <p:txBody>
-          <a:bodyPr wrap="square" lIns="204089" tIns="0" rIns="0" bIns="0" rtlCol="0" anchor="t">
-            <a:spAutoFit/>
-          </a:bodyPr>
-          <a:lstStyle/>
-          <a:p>
-            <a:pPr marL="0" indent="0" algn="l">
-              <a:buNone/>
-            </a:pPr>
-            <a:r>
-              <a:rPr lang="en-US" sz="850" dirty="0">
-                <a:solidFill>
-                  <a:srgbClr val="F8FAFC"/>
-                </a:solidFill>
-                <a:latin typeface="Kantumruy Pro" pitchFamily="34" charset="0"/>
-                <a:ea typeface="Kantumruy Pro" pitchFamily="34" charset="-122"/>
-                <a:cs typeface="Kantumruy Pro" pitchFamily="34" charset="-120"/>
-              </a:rPr>
-              <a:t>Delete Post</a:t>
-            </a:r>
-            <a:endParaRPr lang="en-US" sz="850" dirty="0"/>
-          </a:p>
-        </p:txBody>
-      </p:sp>
-      <p:sp>
-        <p:nvSpPr>
-          <p:cNvPr id="11" name="Text 7">
-            <a:extLst>
-              <a:ext uri="{FF2B5EF4-FFF2-40B4-BE49-F238E27FC236}">
-                <a16:creationId xmlns:a16="http://schemas.microsoft.com/office/drawing/2014/main" id="{1D80ABCA-DA3A-1C0E-8785-10DEAB363FEC}"/>
-              </a:ext>
-            </a:extLst>
-          </p:cNvPr>
-          <p:cNvSpPr/>
-          <p:nvPr/>
-        </p:nvSpPr>
-        <p:spPr>
-          <a:xfrm>
-            <a:off x="2820079" y="2802104"/>
-            <a:ext cx="3571875" cy="132159"/>
-          </a:xfrm>
-          <a:prstGeom prst="rect">
-            <a:avLst/>
-          </a:prstGeom>
-          <a:noFill/>
-          <a:ln/>
-        </p:spPr>
-        <p:txBody>
-          <a:bodyPr wrap="square" lIns="204089" tIns="0" rIns="0" bIns="0" rtlCol="0" anchor="t">
-            <a:spAutoFit/>
-          </a:bodyPr>
-          <a:lstStyle/>
-          <a:p>
-            <a:pPr marL="0" indent="0" algn="l">
-              <a:buNone/>
-            </a:pPr>
-            <a:r>
-              <a:rPr lang="en-US" sz="850" dirty="0">
-                <a:solidFill>
-                  <a:srgbClr val="F8FAFC"/>
-                </a:solidFill>
-                <a:latin typeface="Kantumruy Pro" pitchFamily="34" charset="0"/>
-                <a:ea typeface="Kantumruy Pro" pitchFamily="34" charset="-122"/>
-                <a:cs typeface="Kantumruy Pro" pitchFamily="34" charset="-120"/>
-              </a:rPr>
-              <a:t>Pull-to-Refresh</a:t>
-            </a:r>
-            <a:endParaRPr lang="en-US" sz="850" dirty="0"/>
-          </a:p>
-        </p:txBody>
-      </p:sp>
-      <p:sp>
-        <p:nvSpPr>
-          <p:cNvPr id="13" name="Text 9">
-            <a:extLst>
-              <a:ext uri="{FF2B5EF4-FFF2-40B4-BE49-F238E27FC236}">
-                <a16:creationId xmlns:a16="http://schemas.microsoft.com/office/drawing/2014/main" id="{00FD8B77-F34B-AFDE-393B-C50B1D65A725}"/>
-              </a:ext>
-            </a:extLst>
-          </p:cNvPr>
-          <p:cNvSpPr/>
-          <p:nvPr/>
-        </p:nvSpPr>
-        <p:spPr>
-          <a:xfrm>
-            <a:off x="2696698" y="1937827"/>
-            <a:ext cx="114300" cy="132159"/>
-          </a:xfrm>
-          <a:prstGeom prst="rect">
-            <a:avLst/>
-          </a:prstGeom>
-          <a:noFill/>
-          <a:ln/>
-        </p:spPr>
-        <p:txBody>
-          <a:bodyPr wrap="none" lIns="0" tIns="0" rIns="0" bIns="0" rtlCol="0" anchor="t">
-            <a:spAutoFit/>
-          </a:bodyPr>
-          <a:lstStyle/>
-          <a:p>
-            <a:pPr marL="0" indent="0" algn="l">
-              <a:buNone/>
-            </a:pPr>
-            <a:r>
-              <a:rPr lang="en-US" sz="850" dirty="0">
-                <a:solidFill>
-                  <a:srgbClr val="F59E0B"/>
-                </a:solidFill>
-                <a:latin typeface="Kantumruy Pro" pitchFamily="34" charset="0"/>
-                <a:ea typeface="Kantumruy Pro" pitchFamily="34" charset="-122"/>
-                <a:cs typeface="Kantumruy Pro" pitchFamily="34" charset="-120"/>
-              </a:rPr>
-              <a:t>→</a:t>
-            </a:r>
-            <a:endParaRPr lang="en-US" sz="850" dirty="0"/>
-          </a:p>
-        </p:txBody>
-      </p:sp>
-      <p:sp>
-        <p:nvSpPr>
-          <p:cNvPr id="14" name="Text 10">
-            <a:extLst>
-              <a:ext uri="{FF2B5EF4-FFF2-40B4-BE49-F238E27FC236}">
-                <a16:creationId xmlns:a16="http://schemas.microsoft.com/office/drawing/2014/main" id="{C3945E02-EEFE-AFC5-EC12-E3F80DA59D30}"/>
-              </a:ext>
-            </a:extLst>
-          </p:cNvPr>
-          <p:cNvSpPr/>
-          <p:nvPr/>
-        </p:nvSpPr>
-        <p:spPr>
-          <a:xfrm>
-            <a:off x="2696698" y="2155712"/>
-            <a:ext cx="114300" cy="132159"/>
-          </a:xfrm>
-          <a:prstGeom prst="rect">
-            <a:avLst/>
-          </a:prstGeom>
-          <a:noFill/>
-          <a:ln/>
-        </p:spPr>
-        <p:txBody>
-          <a:bodyPr wrap="none" lIns="0" tIns="0" rIns="0" bIns="0" rtlCol="0" anchor="t">
-            <a:spAutoFit/>
-          </a:bodyPr>
-          <a:lstStyle/>
-          <a:p>
-            <a:pPr marL="0" indent="0" algn="l">
-              <a:buNone/>
-            </a:pPr>
-            <a:r>
-              <a:rPr lang="en-US" sz="850" dirty="0">
-                <a:solidFill>
-                  <a:srgbClr val="F59E0B"/>
-                </a:solidFill>
-                <a:latin typeface="Kantumruy Pro" pitchFamily="34" charset="0"/>
-                <a:ea typeface="Kantumruy Pro" pitchFamily="34" charset="-122"/>
-                <a:cs typeface="Kantumruy Pro" pitchFamily="34" charset="-120"/>
-              </a:rPr>
-              <a:t>→</a:t>
-            </a:r>
-            <a:endParaRPr lang="en-US" sz="850" dirty="0"/>
-          </a:p>
-        </p:txBody>
-      </p:sp>
-      <p:sp>
-        <p:nvSpPr>
-          <p:cNvPr id="15" name="Text 11">
-            <a:extLst>
-              <a:ext uri="{FF2B5EF4-FFF2-40B4-BE49-F238E27FC236}">
-                <a16:creationId xmlns:a16="http://schemas.microsoft.com/office/drawing/2014/main" id="{94B1E027-A547-AB16-A0C2-5950219C503B}"/>
-              </a:ext>
-            </a:extLst>
-          </p:cNvPr>
-          <p:cNvSpPr/>
-          <p:nvPr/>
-        </p:nvSpPr>
-        <p:spPr>
-          <a:xfrm>
-            <a:off x="2696698" y="2373596"/>
-            <a:ext cx="114300" cy="132159"/>
-          </a:xfrm>
-          <a:prstGeom prst="rect">
-            <a:avLst/>
-          </a:prstGeom>
-          <a:noFill/>
-          <a:ln/>
-        </p:spPr>
-        <p:txBody>
-          <a:bodyPr wrap="none" lIns="0" tIns="0" rIns="0" bIns="0" rtlCol="0" anchor="t">
-            <a:spAutoFit/>
-          </a:bodyPr>
-          <a:lstStyle/>
-          <a:p>
-            <a:pPr marL="0" indent="0" algn="l">
-              <a:buNone/>
-            </a:pPr>
-            <a:r>
-              <a:rPr lang="en-US" sz="850" dirty="0">
-                <a:solidFill>
-                  <a:srgbClr val="F59E0B"/>
-                </a:solidFill>
-                <a:latin typeface="Kantumruy Pro" pitchFamily="34" charset="0"/>
-                <a:ea typeface="Kantumruy Pro" pitchFamily="34" charset="-122"/>
-                <a:cs typeface="Kantumruy Pro" pitchFamily="34" charset="-120"/>
-              </a:rPr>
-              <a:t>→</a:t>
-            </a:r>
-            <a:endParaRPr lang="en-US" sz="850" dirty="0"/>
-          </a:p>
-        </p:txBody>
-      </p:sp>
-      <p:sp>
-        <p:nvSpPr>
-          <p:cNvPr id="16" name="Text 12">
-            <a:extLst>
-              <a:ext uri="{FF2B5EF4-FFF2-40B4-BE49-F238E27FC236}">
-                <a16:creationId xmlns:a16="http://schemas.microsoft.com/office/drawing/2014/main" id="{EC1320F2-EFF1-B385-A9F8-F094144A204E}"/>
-              </a:ext>
-            </a:extLst>
-          </p:cNvPr>
-          <p:cNvSpPr/>
-          <p:nvPr/>
-        </p:nvSpPr>
-        <p:spPr>
-          <a:xfrm>
-            <a:off x="2696698" y="2591481"/>
-            <a:ext cx="114300" cy="132159"/>
-          </a:xfrm>
-          <a:prstGeom prst="rect">
-            <a:avLst/>
-          </a:prstGeom>
-          <a:noFill/>
-          <a:ln/>
-        </p:spPr>
-        <p:txBody>
-          <a:bodyPr wrap="none" lIns="0" tIns="0" rIns="0" bIns="0" rtlCol="0" anchor="t">
-            <a:spAutoFit/>
-          </a:bodyPr>
-          <a:lstStyle/>
-          <a:p>
-            <a:pPr marL="0" indent="0" algn="l">
-              <a:buNone/>
-            </a:pPr>
-            <a:r>
-              <a:rPr lang="en-US" sz="850" dirty="0">
-                <a:solidFill>
-                  <a:srgbClr val="F59E0B"/>
-                </a:solidFill>
-                <a:latin typeface="Kantumruy Pro" pitchFamily="34" charset="0"/>
-                <a:ea typeface="Kantumruy Pro" pitchFamily="34" charset="-122"/>
-                <a:cs typeface="Kantumruy Pro" pitchFamily="34" charset="-120"/>
-              </a:rPr>
-              <a:t>→</a:t>
-            </a:r>
-            <a:endParaRPr lang="en-US" sz="850" dirty="0"/>
-          </a:p>
-        </p:txBody>
-      </p:sp>
-      <p:sp>
-        <p:nvSpPr>
-          <p:cNvPr id="17" name="Text 13">
-            <a:extLst>
-              <a:ext uri="{FF2B5EF4-FFF2-40B4-BE49-F238E27FC236}">
-                <a16:creationId xmlns:a16="http://schemas.microsoft.com/office/drawing/2014/main" id="{1BE8E37F-4996-44C1-17E0-5BCD841C01F7}"/>
-              </a:ext>
-            </a:extLst>
-          </p:cNvPr>
-          <p:cNvSpPr/>
-          <p:nvPr/>
-        </p:nvSpPr>
-        <p:spPr>
-          <a:xfrm>
-            <a:off x="2696698" y="2809365"/>
-            <a:ext cx="114300" cy="132159"/>
-          </a:xfrm>
-          <a:prstGeom prst="rect">
-            <a:avLst/>
-          </a:prstGeom>
-          <a:noFill/>
-          <a:ln/>
-        </p:spPr>
-        <p:txBody>
-          <a:bodyPr wrap="none" lIns="0" tIns="0" rIns="0" bIns="0" rtlCol="0" anchor="t">
-            <a:spAutoFit/>
-          </a:bodyPr>
-          <a:lstStyle/>
-          <a:p>
-            <a:pPr marL="0" indent="0" algn="l">
-              <a:buNone/>
-            </a:pPr>
-            <a:r>
-              <a:rPr lang="en-US" sz="850" dirty="0">
-                <a:solidFill>
-                  <a:srgbClr val="F59E0B"/>
-                </a:solidFill>
-                <a:latin typeface="Kantumruy Pro" pitchFamily="34" charset="0"/>
-                <a:ea typeface="Kantumruy Pro" pitchFamily="34" charset="-122"/>
-                <a:cs typeface="Kantumruy Pro" pitchFamily="34" charset="-120"/>
-              </a:rPr>
-              <a:t>→</a:t>
-            </a:r>
-            <a:endParaRPr lang="en-US" sz="850" dirty="0"/>
-          </a:p>
-        </p:txBody>
-      </p:sp>
-      <p:sp>
-        <p:nvSpPr>
           <p:cNvPr id="29" name="Text 25">
             <a:extLst>
               <a:ext uri="{FF2B5EF4-FFF2-40B4-BE49-F238E27FC236}">
@@ -4066,192 +3596,6 @@
               <a:t>6</a:t>
             </a:r>
             <a:endParaRPr lang="en-US" sz="750" dirty="0"/>
-          </a:p>
-        </p:txBody>
-      </p:sp>
-      <p:sp>
-        <p:nvSpPr>
-          <p:cNvPr id="31" name="Text 6">
-            <a:extLst>
-              <a:ext uri="{FF2B5EF4-FFF2-40B4-BE49-F238E27FC236}">
-                <a16:creationId xmlns:a16="http://schemas.microsoft.com/office/drawing/2014/main" id="{F2F42D4F-2205-DC44-13B8-6AC530A0D425}"/>
-              </a:ext>
-            </a:extLst>
-          </p:cNvPr>
-          <p:cNvSpPr/>
-          <p:nvPr/>
-        </p:nvSpPr>
-        <p:spPr>
-          <a:xfrm>
-            <a:off x="2820078" y="3014942"/>
-            <a:ext cx="3571875" cy="132159"/>
-          </a:xfrm>
-          <a:prstGeom prst="rect">
-            <a:avLst/>
-          </a:prstGeom>
-          <a:noFill/>
-          <a:ln/>
-        </p:spPr>
-        <p:txBody>
-          <a:bodyPr wrap="square" lIns="204089" tIns="0" rIns="0" bIns="0" rtlCol="0" anchor="t">
-            <a:spAutoFit/>
-          </a:bodyPr>
-          <a:lstStyle/>
-          <a:p>
-            <a:pPr marL="0" indent="0" algn="l">
-              <a:buNone/>
-            </a:pPr>
-            <a:r>
-              <a:rPr lang="en-US" sz="850" dirty="0">
-                <a:solidFill>
-                  <a:srgbClr val="F8FAFC"/>
-                </a:solidFill>
-                <a:latin typeface="Kantumruy Pro" pitchFamily="34" charset="0"/>
-                <a:cs typeface="Kantumruy Pro" pitchFamily="34" charset="-120"/>
-              </a:rPr>
-              <a:t>Comment</a:t>
-            </a:r>
-            <a:endParaRPr lang="en-US" sz="850" dirty="0"/>
-          </a:p>
-        </p:txBody>
-      </p:sp>
-      <p:sp>
-        <p:nvSpPr>
-          <p:cNvPr id="35" name="Text 13">
-            <a:extLst>
-              <a:ext uri="{FF2B5EF4-FFF2-40B4-BE49-F238E27FC236}">
-                <a16:creationId xmlns:a16="http://schemas.microsoft.com/office/drawing/2014/main" id="{3DDFED69-882A-D765-5213-D17DE0DD75B0}"/>
-              </a:ext>
-            </a:extLst>
-          </p:cNvPr>
-          <p:cNvSpPr/>
-          <p:nvPr/>
-        </p:nvSpPr>
-        <p:spPr>
-          <a:xfrm>
-            <a:off x="2696698" y="3037964"/>
-            <a:ext cx="114300" cy="132159"/>
-          </a:xfrm>
-          <a:prstGeom prst="rect">
-            <a:avLst/>
-          </a:prstGeom>
-          <a:noFill/>
-          <a:ln/>
-        </p:spPr>
-        <p:txBody>
-          <a:bodyPr wrap="none" lIns="0" tIns="0" rIns="0" bIns="0" rtlCol="0" anchor="t">
-            <a:spAutoFit/>
-          </a:bodyPr>
-          <a:lstStyle/>
-          <a:p>
-            <a:pPr marL="0" indent="0" algn="l">
-              <a:buNone/>
-            </a:pPr>
-            <a:r>
-              <a:rPr lang="en-US" sz="850" dirty="0">
-                <a:solidFill>
-                  <a:srgbClr val="F59E0B"/>
-                </a:solidFill>
-                <a:latin typeface="Kantumruy Pro" pitchFamily="34" charset="0"/>
-                <a:ea typeface="Kantumruy Pro" pitchFamily="34" charset="-122"/>
-                <a:cs typeface="Kantumruy Pro" pitchFamily="34" charset="-120"/>
-              </a:rPr>
-              <a:t>→</a:t>
-            </a:r>
-            <a:endParaRPr lang="en-US" sz="850" dirty="0"/>
-          </a:p>
-        </p:txBody>
-      </p:sp>
-      <p:sp>
-        <p:nvSpPr>
-          <p:cNvPr id="37" name="Text 13">
-            <a:extLst>
-              <a:ext uri="{FF2B5EF4-FFF2-40B4-BE49-F238E27FC236}">
-                <a16:creationId xmlns:a16="http://schemas.microsoft.com/office/drawing/2014/main" id="{72C6CDA8-16E5-3440-2EBC-4C5119CB8749}"/>
-              </a:ext>
-            </a:extLst>
-          </p:cNvPr>
-          <p:cNvSpPr/>
-          <p:nvPr/>
-        </p:nvSpPr>
-        <p:spPr>
-          <a:xfrm>
-            <a:off x="2696698" y="3252275"/>
-            <a:ext cx="114300" cy="132159"/>
-          </a:xfrm>
-          <a:prstGeom prst="rect">
-            <a:avLst/>
-          </a:prstGeom>
-          <a:noFill/>
-          <a:ln/>
-        </p:spPr>
-        <p:txBody>
-          <a:bodyPr wrap="none" lIns="0" tIns="0" rIns="0" bIns="0" rtlCol="0" anchor="t">
-            <a:spAutoFit/>
-          </a:bodyPr>
-          <a:lstStyle/>
-          <a:p>
-            <a:pPr marL="0" indent="0" algn="l">
-              <a:buNone/>
-            </a:pPr>
-            <a:r>
-              <a:rPr lang="en-US" sz="850" dirty="0">
-                <a:solidFill>
-                  <a:srgbClr val="F59E0B"/>
-                </a:solidFill>
-                <a:latin typeface="Kantumruy Pro" pitchFamily="34" charset="0"/>
-                <a:ea typeface="Kantumruy Pro" pitchFamily="34" charset="-122"/>
-                <a:cs typeface="Kantumruy Pro" pitchFamily="34" charset="-120"/>
-              </a:rPr>
-              <a:t>→</a:t>
-            </a:r>
-            <a:endParaRPr lang="en-US" sz="850" dirty="0"/>
-          </a:p>
-        </p:txBody>
-      </p:sp>
-      <p:sp>
-        <p:nvSpPr>
-          <p:cNvPr id="39" name="Text 6">
-            <a:extLst>
-              <a:ext uri="{FF2B5EF4-FFF2-40B4-BE49-F238E27FC236}">
-                <a16:creationId xmlns:a16="http://schemas.microsoft.com/office/drawing/2014/main" id="{8DE404C6-0F8D-02A0-4E2A-7F5385A756EB}"/>
-              </a:ext>
-            </a:extLst>
-          </p:cNvPr>
-          <p:cNvSpPr/>
-          <p:nvPr/>
-        </p:nvSpPr>
-        <p:spPr>
-          <a:xfrm>
-            <a:off x="2820077" y="3245014"/>
-            <a:ext cx="3571875" cy="132159"/>
-          </a:xfrm>
-          <a:prstGeom prst="rect">
-            <a:avLst/>
-          </a:prstGeom>
-          <a:noFill/>
-          <a:ln/>
-        </p:spPr>
-        <p:txBody>
-          <a:bodyPr wrap="square" lIns="204089" tIns="0" rIns="0" bIns="0" rtlCol="0" anchor="t">
-            <a:spAutoFit/>
-          </a:bodyPr>
-          <a:lstStyle/>
-          <a:p>
-            <a:pPr marL="0" indent="0" algn="l">
-              <a:buNone/>
-            </a:pPr>
-            <a:r>
-              <a:rPr lang="en-US" sz="850" dirty="0">
-                <a:solidFill>
-                  <a:srgbClr val="F8FAFC"/>
-                </a:solidFill>
-                <a:latin typeface="Kantumruy Pro" pitchFamily="34" charset="0"/>
-                <a:cs typeface="Kantumruy Pro" pitchFamily="34" charset="-120"/>
-              </a:rPr>
-              <a:t>Upload Image</a:t>
-            </a:r>
-            <a:endParaRPr lang="en-US" sz="850" dirty="0"/>
           </a:p>
         </p:txBody>
       </p:sp>

</xml_diff>